<commit_message>
feat: F1b slide renderer — paint the slide model to a QImage
SlideRenderer::render() draws backgrounds, positioned text (font/size/weight/
color), embedded images, letterboxing, and visible placeholders for unsupported
elements and missing/disallowed images. Pure, deterministic, headless. Extends
F1a's model+loader with image bytes and positioned unsupported-element placeholders.

Tests (23 renderer cases, all green): backgrounds, text color/size/position,
images, letterbox, placeholders, Karl's 7 orchestrator assertions (test gate),
and 4 security-audit regressions. Runs under headless QGuiApplication.

Security audit (2 parallel agents, docs/security-audits/f1b-slide-renderer-security-audit.md):
1 Critical (font-size giant-glyph hang) + 2 High (untrusted image-codec allow-list,
unbounded text/paragraphs) fixed test-first, plus clip-rect + pixel/alloc caps.
semgrep 0. Full suite 40/40.

Co-Authored-By: Claude Fable 5 <noreply@anthropic.com>
</commit_message>
<xml_diff>
--- a/tests/fixtures/good_unsupported.pptx
+++ b/tests/fixtures/good_unsupported.pptx
@@ -34,6 +34,10 @@
         </p:txBody>
       </p:sp>
       <p:graphicFrame>
+        <p:xfrm>
+          <a:off x="2000000" y="3000000"/>
+          <a:ext cx="6000000" cy="2000000"/>
+        </p:xfrm>
         <a:graphic>
           <a:graphicData uri="http://schemas.openxmlformats.org/drawingml/2006/table">
             <a:tbl>

</xml_diff>